<commit_message>
feat: add Standard Bank logo to app header
</commit_message>
<xml_diff>
--- a/docs/Payment-Triage-Harness.pptx
+++ b/docs/Payment-Triage-Harness.pptx
@@ -1725,7 +1725,7 @@
         <p:spPr>
           <a:xfrm>
             <a:off x="640080" y="868680"/>
-            <a:ext cx="7315200" cy="320040"/>
+            <a:ext cx="7772400" cy="320040"/>
           </a:xfrm>
           <a:prstGeom prst="rect">
             <a:avLst/>
@@ -1749,7 +1749,7 @@
                 <a:ea typeface="Calibri" pitchFamily="34" charset="-122"/>
                 <a:cs typeface="Calibri" pitchFamily="34" charset="-120"/>
               </a:rPr>
-              <a:t>USE CASE 1 · SPEC-DRIVEN DELIVERY</a:t>
+              <a:t>USE CASE 1  ·  TEAM 45  ·  HARNESS ENGINEER VIEW</a:t>
             </a:r>
             <a:endParaRPr lang="en-US" sz="1300" dirty="0"/>
           </a:p>
@@ -1842,7 +1842,7 @@
         <p:spPr>
           <a:xfrm>
             <a:off x="640080" y="4160520"/>
-            <a:ext cx="7315200" cy="365760"/>
+            <a:ext cx="7772400" cy="365760"/>
           </a:xfrm>
           <a:prstGeom prst="rect">
             <a:avLst/>
@@ -1866,7 +1866,7 @@
                 <a:ea typeface="Calibri" pitchFamily="34" charset="-122"/>
                 <a:cs typeface="Calibri" pitchFamily="34" charset="-120"/>
               </a:rPr>
-              <a:t>Harness Engineer view</a:t>
+              <a:t>Software Engineering Conference 2026</a:t>
             </a:r>
             <a:pPr indent="0" marL="0">
               <a:buNone/>
@@ -1880,7 +1880,7 @@
                 <a:ea typeface="Calibri" pitchFamily="34" charset="-122"/>
                 <a:cs typeface="Calibri" pitchFamily="34" charset="-120"/>
               </a:rPr>
-              <a:t>   ·   Engineering Community of Practice</a:t>
+              <a:t>   ·   22–23 June  ·  Liberty, Johannesburg</a:t>
             </a:r>
             <a:endParaRPr lang="en-US" sz="1300" dirty="0"/>
           </a:p>
@@ -4575,7 +4575,7 @@
                 <a:ea typeface="Calibri" pitchFamily="34" charset="-122"/>
                 <a:cs typeface="Calibri" pitchFamily="34" charset="-120"/>
               </a:rPr>
-              <a:t>docs/  —  human artefacts</a:t>
+              <a:t>Five specification roles  →  docs/</a:t>
             </a:r>
             <a:endParaRPr lang="en-US" sz="1400" dirty="0"/>
           </a:p>
@@ -4589,7 +4589,7 @@
         </p:nvSpPr>
         <p:spPr>
           <a:xfrm>
-            <a:off x="868680" y="2194560"/>
+            <a:off x="868680" y="2286000"/>
             <a:ext cx="1783080" cy="320040"/>
           </a:xfrm>
           <a:prstGeom prst="rect">
@@ -4628,8 +4628,8 @@
         </p:nvSpPr>
         <p:spPr>
           <a:xfrm>
-            <a:off x="2697480" y="2194560"/>
-            <a:ext cx="1920240" cy="320040"/>
+            <a:off x="2697480" y="2286000"/>
+            <a:ext cx="1965960" cy="320040"/>
           </a:xfrm>
           <a:prstGeom prst="rect">
             <a:avLst/>
@@ -4667,7 +4667,7 @@
         </p:nvSpPr>
         <p:spPr>
           <a:xfrm>
-            <a:off x="868680" y="2578608"/>
+            <a:off x="868680" y="2706624"/>
             <a:ext cx="1783080" cy="320040"/>
           </a:xfrm>
           <a:prstGeom prst="rect">
@@ -4692,6 +4692,240 @@
                 <a:ea typeface="Calibri" pitchFamily="34" charset="-122"/>
                 <a:cs typeface="Calibri" pitchFamily="34" charset="-120"/>
               </a:rPr>
+              <a:t>Quality Engineer</a:t>
+            </a:r>
+            <a:endParaRPr lang="en-US" sz="1250" dirty="0"/>
+          </a:p>
+        </p:txBody>
+      </p:sp>
+      <p:sp>
+        <p:nvSpPr>
+          <p:cNvPr id="9" name="Text 7"/>
+          <p:cNvSpPr/>
+          <p:nvPr/>
+        </p:nvSpPr>
+        <p:spPr>
+          <a:xfrm>
+            <a:off x="2697480" y="2706624"/>
+            <a:ext cx="1965960" cy="320040"/>
+          </a:xfrm>
+          <a:prstGeom prst="rect">
+            <a:avLst/>
+          </a:prstGeom>
+          <a:noFill/>
+          <a:ln/>
+        </p:spPr>
+        <p:txBody>
+          <a:bodyPr wrap="square" lIns="0" tIns="0" rIns="0" bIns="0" rtlCol="0" anchor="ctr"/>
+          <a:lstStyle/>
+          <a:p>
+            <a:pPr indent="0" marL="0">
+              <a:buNone/>
+            </a:pPr>
+            <a:r>
+              <a:rPr lang="en-US" sz="1200" dirty="0">
+                <a:solidFill>
+                  <a:srgbClr val="64748B"/>
+                </a:solidFill>
+                <a:latin typeface="Calibri" pitchFamily="34" charset="0"/>
+                <a:ea typeface="Calibri" pitchFamily="34" charset="-122"/>
+                <a:cs typeface="Calibri" pitchFamily="34" charset="-120"/>
+              </a:rPr>
+              <a:t>test-cases.md (51, GWT)</a:t>
+            </a:r>
+            <a:endParaRPr lang="en-US" sz="1200" dirty="0"/>
+          </a:p>
+        </p:txBody>
+      </p:sp>
+      <p:sp>
+        <p:nvSpPr>
+          <p:cNvPr id="10" name="Text 8"/>
+          <p:cNvSpPr/>
+          <p:nvPr/>
+        </p:nvSpPr>
+        <p:spPr>
+          <a:xfrm>
+            <a:off x="868680" y="3127248"/>
+            <a:ext cx="1783080" cy="320040"/>
+          </a:xfrm>
+          <a:prstGeom prst="rect">
+            <a:avLst/>
+          </a:prstGeom>
+          <a:noFill/>
+          <a:ln/>
+        </p:spPr>
+        <p:txBody>
+          <a:bodyPr wrap="square" lIns="0" tIns="0" rIns="0" bIns="0" rtlCol="0" anchor="ctr"/>
+          <a:lstStyle/>
+          <a:p>
+            <a:pPr indent="0" marL="0">
+              <a:buNone/>
+            </a:pPr>
+            <a:r>
+              <a:rPr lang="en-US" sz="1250" b="1" dirty="0">
+                <a:solidFill>
+                  <a:srgbClr val="13294B"/>
+                </a:solidFill>
+                <a:latin typeface="Calibri" pitchFamily="34" charset="0"/>
+                <a:ea typeface="Calibri" pitchFamily="34" charset="-122"/>
+                <a:cs typeface="Calibri" pitchFamily="34" charset="-120"/>
+              </a:rPr>
+              <a:t>API Designer</a:t>
+            </a:r>
+            <a:endParaRPr lang="en-US" sz="1250" dirty="0"/>
+          </a:p>
+        </p:txBody>
+      </p:sp>
+      <p:sp>
+        <p:nvSpPr>
+          <p:cNvPr id="11" name="Text 9"/>
+          <p:cNvSpPr/>
+          <p:nvPr/>
+        </p:nvSpPr>
+        <p:spPr>
+          <a:xfrm>
+            <a:off x="2697480" y="3127248"/>
+            <a:ext cx="1965960" cy="320040"/>
+          </a:xfrm>
+          <a:prstGeom prst="rect">
+            <a:avLst/>
+          </a:prstGeom>
+          <a:noFill/>
+          <a:ln/>
+        </p:spPr>
+        <p:txBody>
+          <a:bodyPr wrap="square" lIns="0" tIns="0" rIns="0" bIns="0" rtlCol="0" anchor="ctr"/>
+          <a:lstStyle/>
+          <a:p>
+            <a:pPr indent="0" marL="0">
+              <a:buNone/>
+            </a:pPr>
+            <a:r>
+              <a:rPr lang="en-US" sz="1200" dirty="0">
+                <a:solidFill>
+                  <a:srgbClr val="64748B"/>
+                </a:solidFill>
+                <a:latin typeface="Calibri" pitchFamily="34" charset="0"/>
+                <a:ea typeface="Calibri" pitchFamily="34" charset="-122"/>
+                <a:cs typeface="Calibri" pitchFamily="34" charset="-120"/>
+              </a:rPr>
+              <a:t>api-spec.md</a:t>
+            </a:r>
+            <a:endParaRPr lang="en-US" sz="1200" dirty="0"/>
+          </a:p>
+        </p:txBody>
+      </p:sp>
+      <p:sp>
+        <p:nvSpPr>
+          <p:cNvPr id="12" name="Text 10"/>
+          <p:cNvSpPr/>
+          <p:nvPr/>
+        </p:nvSpPr>
+        <p:spPr>
+          <a:xfrm>
+            <a:off x="868680" y="3547872"/>
+            <a:ext cx="1783080" cy="320040"/>
+          </a:xfrm>
+          <a:prstGeom prst="rect">
+            <a:avLst/>
+          </a:prstGeom>
+          <a:noFill/>
+          <a:ln/>
+        </p:spPr>
+        <p:txBody>
+          <a:bodyPr wrap="square" lIns="0" tIns="0" rIns="0" bIns="0" rtlCol="0" anchor="ctr"/>
+          <a:lstStyle/>
+          <a:p>
+            <a:pPr indent="0" marL="0">
+              <a:buNone/>
+            </a:pPr>
+            <a:r>
+              <a:rPr lang="en-US" sz="1250" b="1" dirty="0">
+                <a:solidFill>
+                  <a:srgbClr val="13294B"/>
+                </a:solidFill>
+                <a:latin typeface="Calibri" pitchFamily="34" charset="0"/>
+                <a:ea typeface="Calibri" pitchFamily="34" charset="-122"/>
+                <a:cs typeface="Calibri" pitchFamily="34" charset="-120"/>
+              </a:rPr>
+              <a:t>UI/UX Designer</a:t>
+            </a:r>
+            <a:endParaRPr lang="en-US" sz="1250" dirty="0"/>
+          </a:p>
+        </p:txBody>
+      </p:sp>
+      <p:sp>
+        <p:nvSpPr>
+          <p:cNvPr id="13" name="Text 11"/>
+          <p:cNvSpPr/>
+          <p:nvPr/>
+        </p:nvSpPr>
+        <p:spPr>
+          <a:xfrm>
+            <a:off x="2697480" y="3547872"/>
+            <a:ext cx="1965960" cy="320040"/>
+          </a:xfrm>
+          <a:prstGeom prst="rect">
+            <a:avLst/>
+          </a:prstGeom>
+          <a:noFill/>
+          <a:ln/>
+        </p:spPr>
+        <p:txBody>
+          <a:bodyPr wrap="square" lIns="0" tIns="0" rIns="0" bIns="0" rtlCol="0" anchor="ctr"/>
+          <a:lstStyle/>
+          <a:p>
+            <a:pPr indent="0" marL="0">
+              <a:buNone/>
+            </a:pPr>
+            <a:r>
+              <a:rPr lang="en-US" sz="1200" dirty="0">
+                <a:solidFill>
+                  <a:srgbClr val="64748B"/>
+                </a:solidFill>
+                <a:latin typeface="Calibri" pitchFamily="34" charset="0"/>
+                <a:ea typeface="Calibri" pitchFamily="34" charset="-122"/>
+                <a:cs typeface="Calibri" pitchFamily="34" charset="-120"/>
+              </a:rPr>
+              <a:t>ui-spec.md</a:t>
+            </a:r>
+            <a:endParaRPr lang="en-US" sz="1200" dirty="0"/>
+          </a:p>
+        </p:txBody>
+      </p:sp>
+      <p:sp>
+        <p:nvSpPr>
+          <p:cNvPr id="14" name="Text 12"/>
+          <p:cNvSpPr/>
+          <p:nvPr/>
+        </p:nvSpPr>
+        <p:spPr>
+          <a:xfrm>
+            <a:off x="868680" y="3968496"/>
+            <a:ext cx="1783080" cy="320040"/>
+          </a:xfrm>
+          <a:prstGeom prst="rect">
+            <a:avLst/>
+          </a:prstGeom>
+          <a:noFill/>
+          <a:ln/>
+        </p:spPr>
+        <p:txBody>
+          <a:bodyPr wrap="square" lIns="0" tIns="0" rIns="0" bIns="0" rtlCol="0" anchor="ctr"/>
+          <a:lstStyle/>
+          <a:p>
+            <a:pPr indent="0" marL="0">
+              <a:buNone/>
+            </a:pPr>
+            <a:r>
+              <a:rPr lang="en-US" sz="1250" b="1" dirty="0">
+                <a:solidFill>
+                  <a:srgbClr val="13294B"/>
+                </a:solidFill>
+                <a:latin typeface="Calibri" pitchFamily="34" charset="0"/>
+                <a:ea typeface="Calibri" pitchFamily="34" charset="-122"/>
+                <a:cs typeface="Calibri" pitchFamily="34" charset="-120"/>
+              </a:rPr>
               <a:t>Architect</a:t>
             </a:r>
             <a:endParaRPr lang="en-US" sz="1250" dirty="0"/>
@@ -4700,14 +4934,14 @@
       </p:sp>
       <p:sp>
         <p:nvSpPr>
-          <p:cNvPr id="9" name="Text 7"/>
-          <p:cNvSpPr/>
-          <p:nvPr/>
-        </p:nvSpPr>
-        <p:spPr>
-          <a:xfrm>
-            <a:off x="2697480" y="2578608"/>
-            <a:ext cx="1920240" cy="320040"/>
+          <p:cNvPr id="15" name="Text 13"/>
+          <p:cNvSpPr/>
+          <p:nvPr/>
+        </p:nvSpPr>
+        <p:spPr>
+          <a:xfrm>
+            <a:off x="2697480" y="3968496"/>
+            <a:ext cx="1965960" cy="320040"/>
           </a:xfrm>
           <a:prstGeom prst="rect">
             <a:avLst/>
@@ -4731,7 +4965,7 @@
                 <a:ea typeface="Calibri" pitchFamily="34" charset="-122"/>
                 <a:cs typeface="Calibri" pitchFamily="34" charset="-120"/>
               </a:rPr>
-              <a:t>architecture.md</a:t>
+              <a:t>architecture.md + rules engine</a:t>
             </a:r>
             <a:endParaRPr lang="en-US" sz="1200" dirty="0"/>
           </a:p>
@@ -4739,319 +4973,7 @@
       </p:sp>
       <p:sp>
         <p:nvSpPr>
-          <p:cNvPr id="10" name="Text 8"/>
-          <p:cNvSpPr/>
-          <p:nvPr/>
-        </p:nvSpPr>
-        <p:spPr>
-          <a:xfrm>
-            <a:off x="868680" y="2962656"/>
-            <a:ext cx="1783080" cy="320040"/>
-          </a:xfrm>
-          <a:prstGeom prst="rect">
-            <a:avLst/>
-          </a:prstGeom>
-          <a:noFill/>
-          <a:ln/>
-        </p:spPr>
-        <p:txBody>
-          <a:bodyPr wrap="square" lIns="0" tIns="0" rIns="0" bIns="0" rtlCol="0" anchor="ctr"/>
-          <a:lstStyle/>
-          <a:p>
-            <a:pPr indent="0" marL="0">
-              <a:buNone/>
-            </a:pPr>
-            <a:r>
-              <a:rPr lang="en-US" sz="1250" b="1" dirty="0">
-                <a:solidFill>
-                  <a:srgbClr val="13294B"/>
-                </a:solidFill>
-                <a:latin typeface="Calibri" pitchFamily="34" charset="0"/>
-                <a:ea typeface="Calibri" pitchFamily="34" charset="-122"/>
-                <a:cs typeface="Calibri" pitchFamily="34" charset="-120"/>
-              </a:rPr>
-              <a:t>API Designer</a:t>
-            </a:r>
-            <a:endParaRPr lang="en-US" sz="1250" dirty="0"/>
-          </a:p>
-        </p:txBody>
-      </p:sp>
-      <p:sp>
-        <p:nvSpPr>
-          <p:cNvPr id="11" name="Text 9"/>
-          <p:cNvSpPr/>
-          <p:nvPr/>
-        </p:nvSpPr>
-        <p:spPr>
-          <a:xfrm>
-            <a:off x="2697480" y="2962656"/>
-            <a:ext cx="1920240" cy="320040"/>
-          </a:xfrm>
-          <a:prstGeom prst="rect">
-            <a:avLst/>
-          </a:prstGeom>
-          <a:noFill/>
-          <a:ln/>
-        </p:spPr>
-        <p:txBody>
-          <a:bodyPr wrap="square" lIns="0" tIns="0" rIns="0" bIns="0" rtlCol="0" anchor="ctr"/>
-          <a:lstStyle/>
-          <a:p>
-            <a:pPr indent="0" marL="0">
-              <a:buNone/>
-            </a:pPr>
-            <a:r>
-              <a:rPr lang="en-US" sz="1200" dirty="0">
-                <a:solidFill>
-                  <a:srgbClr val="64748B"/>
-                </a:solidFill>
-                <a:latin typeface="Calibri" pitchFamily="34" charset="0"/>
-                <a:ea typeface="Calibri" pitchFamily="34" charset="-122"/>
-                <a:cs typeface="Calibri" pitchFamily="34" charset="-120"/>
-              </a:rPr>
-              <a:t>api-spec.md</a:t>
-            </a:r>
-            <a:endParaRPr lang="en-US" sz="1200" dirty="0"/>
-          </a:p>
-        </p:txBody>
-      </p:sp>
-      <p:sp>
-        <p:nvSpPr>
-          <p:cNvPr id="12" name="Text 10"/>
-          <p:cNvSpPr/>
-          <p:nvPr/>
-        </p:nvSpPr>
-        <p:spPr>
-          <a:xfrm>
-            <a:off x="868680" y="3346704"/>
-            <a:ext cx="1783080" cy="320040"/>
-          </a:xfrm>
-          <a:prstGeom prst="rect">
-            <a:avLst/>
-          </a:prstGeom>
-          <a:noFill/>
-          <a:ln/>
-        </p:spPr>
-        <p:txBody>
-          <a:bodyPr wrap="square" lIns="0" tIns="0" rIns="0" bIns="0" rtlCol="0" anchor="ctr"/>
-          <a:lstStyle/>
-          <a:p>
-            <a:pPr indent="0" marL="0">
-              <a:buNone/>
-            </a:pPr>
-            <a:r>
-              <a:rPr lang="en-US" sz="1250" b="1" dirty="0">
-                <a:solidFill>
-                  <a:srgbClr val="13294B"/>
-                </a:solidFill>
-                <a:latin typeface="Calibri" pitchFamily="34" charset="0"/>
-                <a:ea typeface="Calibri" pitchFamily="34" charset="-122"/>
-                <a:cs typeface="Calibri" pitchFamily="34" charset="-120"/>
-              </a:rPr>
-              <a:t>UI/UX Designer</a:t>
-            </a:r>
-            <a:endParaRPr lang="en-US" sz="1250" dirty="0"/>
-          </a:p>
-        </p:txBody>
-      </p:sp>
-      <p:sp>
-        <p:nvSpPr>
-          <p:cNvPr id="13" name="Text 11"/>
-          <p:cNvSpPr/>
-          <p:nvPr/>
-        </p:nvSpPr>
-        <p:spPr>
-          <a:xfrm>
-            <a:off x="2697480" y="3346704"/>
-            <a:ext cx="1920240" cy="320040"/>
-          </a:xfrm>
-          <a:prstGeom prst="rect">
-            <a:avLst/>
-          </a:prstGeom>
-          <a:noFill/>
-          <a:ln/>
-        </p:spPr>
-        <p:txBody>
-          <a:bodyPr wrap="square" lIns="0" tIns="0" rIns="0" bIns="0" rtlCol="0" anchor="ctr"/>
-          <a:lstStyle/>
-          <a:p>
-            <a:pPr indent="0" marL="0">
-              <a:buNone/>
-            </a:pPr>
-            <a:r>
-              <a:rPr lang="en-US" sz="1200" dirty="0">
-                <a:solidFill>
-                  <a:srgbClr val="64748B"/>
-                </a:solidFill>
-                <a:latin typeface="Calibri" pitchFamily="34" charset="0"/>
-                <a:ea typeface="Calibri" pitchFamily="34" charset="-122"/>
-                <a:cs typeface="Calibri" pitchFamily="34" charset="-120"/>
-              </a:rPr>
-              <a:t>ui-spec.md</a:t>
-            </a:r>
-            <a:endParaRPr lang="en-US" sz="1200" dirty="0"/>
-          </a:p>
-        </p:txBody>
-      </p:sp>
-      <p:sp>
-        <p:nvSpPr>
-          <p:cNvPr id="14" name="Text 12"/>
-          <p:cNvSpPr/>
-          <p:nvPr/>
-        </p:nvSpPr>
-        <p:spPr>
-          <a:xfrm>
-            <a:off x="868680" y="3730752"/>
-            <a:ext cx="1783080" cy="320040"/>
-          </a:xfrm>
-          <a:prstGeom prst="rect">
-            <a:avLst/>
-          </a:prstGeom>
-          <a:noFill/>
-          <a:ln/>
-        </p:spPr>
-        <p:txBody>
-          <a:bodyPr wrap="square" lIns="0" tIns="0" rIns="0" bIns="0" rtlCol="0" anchor="ctr"/>
-          <a:lstStyle/>
-          <a:p>
-            <a:pPr indent="0" marL="0">
-              <a:buNone/>
-            </a:pPr>
-            <a:r>
-              <a:rPr lang="en-US" sz="1250" b="1" dirty="0">
-                <a:solidFill>
-                  <a:srgbClr val="13294B"/>
-                </a:solidFill>
-                <a:latin typeface="Calibri" pitchFamily="34" charset="0"/>
-                <a:ea typeface="Calibri" pitchFamily="34" charset="-122"/>
-                <a:cs typeface="Calibri" pitchFamily="34" charset="-120"/>
-              </a:rPr>
-              <a:t>Test Architect</a:t>
-            </a:r>
-            <a:endParaRPr lang="en-US" sz="1250" dirty="0"/>
-          </a:p>
-        </p:txBody>
-      </p:sp>
-      <p:sp>
-        <p:nvSpPr>
-          <p:cNvPr id="15" name="Text 13"/>
-          <p:cNvSpPr/>
-          <p:nvPr/>
-        </p:nvSpPr>
-        <p:spPr>
-          <a:xfrm>
-            <a:off x="2697480" y="3730752"/>
-            <a:ext cx="1920240" cy="320040"/>
-          </a:xfrm>
-          <a:prstGeom prst="rect">
-            <a:avLst/>
-          </a:prstGeom>
-          <a:noFill/>
-          <a:ln/>
-        </p:spPr>
-        <p:txBody>
-          <a:bodyPr wrap="square" lIns="0" tIns="0" rIns="0" bIns="0" rtlCol="0" anchor="ctr"/>
-          <a:lstStyle/>
-          <a:p>
-            <a:pPr indent="0" marL="0">
-              <a:buNone/>
-            </a:pPr>
-            <a:r>
-              <a:rPr lang="en-US" sz="1200" dirty="0">
-                <a:solidFill>
-                  <a:srgbClr val="64748B"/>
-                </a:solidFill>
-                <a:latin typeface="Calibri" pitchFamily="34" charset="0"/>
-                <a:ea typeface="Calibri" pitchFamily="34" charset="-122"/>
-                <a:cs typeface="Calibri" pitchFamily="34" charset="-120"/>
-              </a:rPr>
-              <a:t>test-cases.md (51 cases)</a:t>
-            </a:r>
-            <a:endParaRPr lang="en-US" sz="1200" dirty="0"/>
-          </a:p>
-        </p:txBody>
-      </p:sp>
-      <p:sp>
-        <p:nvSpPr>
-          <p:cNvPr id="16" name="Text 14"/>
-          <p:cNvSpPr/>
-          <p:nvPr/>
-        </p:nvSpPr>
-        <p:spPr>
-          <a:xfrm>
-            <a:off x="868680" y="4114800"/>
-            <a:ext cx="1783080" cy="320040"/>
-          </a:xfrm>
-          <a:prstGeom prst="rect">
-            <a:avLst/>
-          </a:prstGeom>
-          <a:noFill/>
-          <a:ln/>
-        </p:spPr>
-        <p:txBody>
-          <a:bodyPr wrap="square" lIns="0" tIns="0" rIns="0" bIns="0" rtlCol="0" anchor="ctr"/>
-          <a:lstStyle/>
-          <a:p>
-            <a:pPr indent="0" marL="0">
-              <a:buNone/>
-            </a:pPr>
-            <a:r>
-              <a:rPr lang="en-US" sz="1250" b="1" dirty="0">
-                <a:solidFill>
-                  <a:srgbClr val="13294B"/>
-                </a:solidFill>
-                <a:latin typeface="Calibri" pitchFamily="34" charset="0"/>
-                <a:ea typeface="Calibri" pitchFamily="34" charset="-122"/>
-                <a:cs typeface="Calibri" pitchFamily="34" charset="-120"/>
-              </a:rPr>
-              <a:t>Quality Engineer</a:t>
-            </a:r>
-            <a:endParaRPr lang="en-US" sz="1250" dirty="0"/>
-          </a:p>
-        </p:txBody>
-      </p:sp>
-      <p:sp>
-        <p:nvSpPr>
-          <p:cNvPr id="17" name="Text 15"/>
-          <p:cNvSpPr/>
-          <p:nvPr/>
-        </p:nvSpPr>
-        <p:spPr>
-          <a:xfrm>
-            <a:off x="2697480" y="4114800"/>
-            <a:ext cx="1920240" cy="320040"/>
-          </a:xfrm>
-          <a:prstGeom prst="rect">
-            <a:avLst/>
-          </a:prstGeom>
-          <a:noFill/>
-          <a:ln/>
-        </p:spPr>
-        <p:txBody>
-          <a:bodyPr wrap="square" lIns="0" tIns="0" rIns="0" bIns="0" rtlCol="0" anchor="ctr"/>
-          <a:lstStyle/>
-          <a:p>
-            <a:pPr indent="0" marL="0">
-              <a:buNone/>
-            </a:pPr>
-            <a:r>
-              <a:rPr lang="en-US" sz="1200" dirty="0">
-                <a:solidFill>
-                  <a:srgbClr val="64748B"/>
-                </a:solidFill>
-                <a:latin typeface="Calibri" pitchFamily="34" charset="0"/>
-                <a:ea typeface="Calibri" pitchFamily="34" charset="-122"/>
-                <a:cs typeface="Calibri" pitchFamily="34" charset="-120"/>
-              </a:rPr>
-              <a:t>test-plan.md (traceability)</a:t>
-            </a:r>
-            <a:endParaRPr lang="en-US" sz="1200" dirty="0"/>
-          </a:p>
-        </p:txBody>
-      </p:sp>
-      <p:sp>
-        <p:nvSpPr>
-          <p:cNvPr id="18" name="Shape 16"/>
+          <p:cNvPr id="16" name="Shape 14"/>
           <p:cNvSpPr/>
           <p:nvPr/>
         </p:nvSpPr>
@@ -5080,7 +5002,7 @@
       </p:sp>
       <p:sp>
         <p:nvSpPr>
-          <p:cNvPr id="19" name="Text 17"/>
+          <p:cNvPr id="17" name="Text 15"/>
           <p:cNvSpPr/>
           <p:nvPr/>
         </p:nvSpPr>
@@ -5119,7 +5041,7 @@
       </p:sp>
       <p:sp>
         <p:nvSpPr>
-          <p:cNvPr id="20" name="Shape 18"/>
+          <p:cNvPr id="18" name="Shape 16"/>
           <p:cNvSpPr/>
           <p:nvPr/>
         </p:nvSpPr>
@@ -5144,7 +5066,7 @@
       </p:sp>
       <p:sp>
         <p:nvSpPr>
-          <p:cNvPr id="21" name="Text 19"/>
+          <p:cNvPr id="19" name="Text 17"/>
           <p:cNvSpPr/>
           <p:nvPr/>
         </p:nvSpPr>
@@ -5183,7 +5105,7 @@
       </p:sp>
       <p:sp>
         <p:nvSpPr>
-          <p:cNvPr id="22" name="Text 20"/>
+          <p:cNvPr id="20" name="Text 18"/>
           <p:cNvSpPr/>
           <p:nvPr/>
         </p:nvSpPr>
@@ -5222,7 +5144,7 @@
       </p:sp>
       <p:sp>
         <p:nvSpPr>
-          <p:cNvPr id="23" name="Text 21"/>
+          <p:cNvPr id="21" name="Text 19"/>
           <p:cNvSpPr/>
           <p:nvPr/>
         </p:nvSpPr>
@@ -5261,7 +5183,7 @@
       </p:sp>
       <p:sp>
         <p:nvSpPr>
-          <p:cNvPr id="24" name="Shape 22"/>
+          <p:cNvPr id="22" name="Shape 20"/>
           <p:cNvSpPr/>
           <p:nvPr/>
         </p:nvSpPr>
@@ -5286,7 +5208,7 @@
       </p:sp>
       <p:sp>
         <p:nvSpPr>
-          <p:cNvPr id="25" name="Text 23"/>
+          <p:cNvPr id="23" name="Text 21"/>
           <p:cNvSpPr/>
           <p:nvPr/>
         </p:nvSpPr>
@@ -5325,7 +5247,7 @@
       </p:sp>
       <p:sp>
         <p:nvSpPr>
-          <p:cNvPr id="26" name="Text 24"/>
+          <p:cNvPr id="24" name="Text 22"/>
           <p:cNvSpPr/>
           <p:nvPr/>
         </p:nvSpPr>
@@ -5364,7 +5286,7 @@
       </p:sp>
       <p:sp>
         <p:nvSpPr>
-          <p:cNvPr id="27" name="Text 25"/>
+          <p:cNvPr id="25" name="Text 23"/>
           <p:cNvSpPr/>
           <p:nvPr/>
         </p:nvSpPr>
@@ -5403,7 +5325,7 @@
       </p:sp>
       <p:sp>
         <p:nvSpPr>
-          <p:cNvPr id="28" name="Shape 26"/>
+          <p:cNvPr id="26" name="Shape 24"/>
           <p:cNvSpPr/>
           <p:nvPr/>
         </p:nvSpPr>
@@ -5428,7 +5350,7 @@
       </p:sp>
       <p:sp>
         <p:nvSpPr>
-          <p:cNvPr id="29" name="Text 27"/>
+          <p:cNvPr id="27" name="Text 25"/>
           <p:cNvSpPr/>
           <p:nvPr/>
         </p:nvSpPr>
@@ -5467,7 +5389,7 @@
       </p:sp>
       <p:sp>
         <p:nvSpPr>
-          <p:cNvPr id="30" name="Text 28"/>
+          <p:cNvPr id="28" name="Text 26"/>
           <p:cNvSpPr/>
           <p:nvPr/>
         </p:nvSpPr>
@@ -5506,7 +5428,7 @@
       </p:sp>
       <p:sp>
         <p:nvSpPr>
-          <p:cNvPr id="31" name="Text 29"/>
+          <p:cNvPr id="29" name="Text 27"/>
           <p:cNvSpPr/>
           <p:nvPr/>
         </p:nvSpPr>

</xml_diff>